<commit_message>
Training decks and cheat sheet for the new Present layout; 0.9.2 release notes
The bundled decks, the key sheet and Training 1 and 2's notes said "the
strip on top", "top left" and "More ›". They now point at the right side,
the On air box, Clear and Remotes, and Close service at the bottom right.

RELEASING.md gains a 0.9.2 section: publish the re-rendered training
videos on release day (0.9.1 downloads them too), what to check in the
desktop app before tagging, and the update notes.

Co-Authored-By: Claude Opus 5.5 <noreply@anthropic.com>
</commit_message>
<xml_diff>
--- a/training/decks/t1-present-screen.pptx
+++ b/training/decks/t1-present-screen.pptx
@@ -595,17 +595,27 @@
           </a:p>
           <a:p>
             <a:r>
-              <a:t>The notes, where you are reading this, sit beside the item on air. The strip on top has a</a:t>
-            </a:r>
-          </a:p>
-          <a:p>
-            <a:r>
-              <a:t>small picture of the main screen, then Focus, Quick add, Previous, Next and Blank. Show, Idle and Blank, top right, switch the room between the slide, the idle</a:t>
-            </a:r>
-          </a:p>
-          <a:p>
-            <a:r>
-              <a:t>screen and black. Press F for Focus to see only the cards; F or Esc brings the rest back.</a:t>
+              <a:t>The notes, where you are reading this, sit beside the item on air. The right side starts with</a:t>
+            </a:r>
+          </a:p>
+          <a:p>
+            <a:r>
+              <a:t>On air: a picture of the main screen, then Previous, Next and Blank. Under it, Show, Idle and</a:t>
+            </a:r>
+          </a:p>
+          <a:p>
+            <a:r>
+              <a:t>Blank switch the room between the slide, the idle screen and black. Below that are Quick add,</a:t>
+            </a:r>
+          </a:p>
+          <a:p>
+            <a:r>
+              <a:t>the sound, and boxes that fold away: Remotes, Clear and Keys. Press F, or Focus at the top</a:t>
+            </a:r>
+          </a:p>
+          <a:p>
+            <a:r>
+              <a:t>right, to see only the cards; F or Esc brings the rest back.</a:t>
             </a:r>
           </a:p>
         </p:txBody>
@@ -4072,7 +4082,7 @@
                 </a:solidFill>
                 <a:latin typeface="Noto Sans"/>
               </a:rPr>
-              <a:t>•  The strip on top: the main screen and the buttons</a:t>
+              <a:t>•  The right side: the main screen and the buttons</a:t>
             </a:r>
           </a:p>
         </p:txBody>

</xml_diff>